<commit_message>
updated ppt for review1
</commit_message>
<xml_diff>
--- a/docs/Review1_Presentation.pptx
+++ b/docs/Review1_Presentation.pptx
@@ -5,7 +5,7 @@
     <p:sldMasterId id="2147483648" r:id="rId1"/>
   </p:sldMasterIdLst>
   <p:notesMasterIdLst>
-    <p:notesMasterId r:id="rId16"/>
+    <p:notesMasterId r:id="rId17"/>
   </p:notesMasterIdLst>
   <p:sldIdLst>
     <p:sldId id="256" r:id="rId2"/>
@@ -20,8 +20,9 @@
     <p:sldId id="274" r:id="rId11"/>
     <p:sldId id="275" r:id="rId12"/>
     <p:sldId id="259" r:id="rId13"/>
-    <p:sldId id="260" r:id="rId14"/>
-    <p:sldId id="269" r:id="rId15"/>
+    <p:sldId id="276" r:id="rId14"/>
+    <p:sldId id="260" r:id="rId15"/>
+    <p:sldId id="269" r:id="rId16"/>
   </p:sldIdLst>
   <p:sldSz cx="9144000" cy="6858000" type="screen4x3"/>
   <p:notesSz cx="9144000" cy="6858000"/>
@@ -270,7 +271,7 @@
       </p15:sldGuideLst>
     </p:ext>
     <p:ext uri="GoogleSlidesCustomDataVersion2">
-      <go:slidesCustomData xmlns:go="http://customooxmlschemas.google.com/" xmlns:ahyp="http://schemas.microsoft.com/office/drawing/2018/hyperlinkcolor" xmlns:p15="http://schemas.microsoft.com/office/powerpoint/2012/main" xmlns:p14="http://schemas.microsoft.com/office/powerpoint/2010/main" xmlns:com="http://schemas.openxmlformats.org/drawingml/2006/compatibility" xmlns:pvml="urn:schemas-microsoft-com:office:powerpoint" xmlns:v="urn:schemas-microsoft-com:vml" xmlns:o="urn:schemas-microsoft-com:office:office" xmlns:dgm="http://schemas.openxmlformats.org/drawingml/2006/diagram" xmlns:c="http://schemas.openxmlformats.org/drawingml/2006/chart" xmlns:mv="urn:schemas-microsoft-com:mac:vml" xmlns:mc="http://schemas.openxmlformats.org/markup-compatibility/2006" xmlns="" r:id="rId17" roundtripDataSignature="AMtx7mjmihMLrrBZE8aYcezI03h6WiDJsw=="/>
+      <go:slidesCustomData xmlns="" xmlns:mc="http://schemas.openxmlformats.org/markup-compatibility/2006" xmlns:mv="urn:schemas-microsoft-com:mac:vml" xmlns:c="http://schemas.openxmlformats.org/drawingml/2006/chart" xmlns:dgm="http://schemas.openxmlformats.org/drawingml/2006/diagram" xmlns:o="urn:schemas-microsoft-com:office:office" xmlns:v="urn:schemas-microsoft-com:vml" xmlns:pvml="urn:schemas-microsoft-com:office:powerpoint" xmlns:com="http://schemas.openxmlformats.org/drawingml/2006/compatibility" xmlns:p14="http://schemas.microsoft.com/office/powerpoint/2010/main" xmlns:p15="http://schemas.microsoft.com/office/powerpoint/2012/main" xmlns:ahyp="http://schemas.microsoft.com/office/drawing/2018/hyperlinkcolor" xmlns:go="http://customooxmlschemas.google.com/" r:id="rId18" roundtripDataSignature="AMtx7mjmihMLrrBZE8aYcezI03h6WiDJsw=="/>
     </p:ext>
   </p:extLst>
 </p:presentation>
@@ -7889,6 +7890,168 @@
   <p:cSld>
     <p:spTree>
       <p:nvGrpSpPr>
+        <p:cNvPr id="1" name=""/>
+        <p:cNvGrpSpPr/>
+        <p:nvPr/>
+      </p:nvGrpSpPr>
+      <p:grpSpPr>
+        <a:xfrm>
+          <a:off x="0" y="0"/>
+          <a:ext cx="0" cy="0"/>
+          <a:chOff x="0" y="0"/>
+          <a:chExt cx="0" cy="0"/>
+        </a:xfrm>
+      </p:grpSpPr>
+      <p:sp>
+        <p:nvSpPr>
+          <p:cNvPr id="2" name="Title 1">
+            <a:extLst>
+              <a:ext uri="{FF2B5EF4-FFF2-40B4-BE49-F238E27FC236}">
+                <a16:creationId xmlns:a16="http://schemas.microsoft.com/office/drawing/2014/main" id="{63F380BB-327B-7B1F-C7B6-6B0C54D1951C}"/>
+              </a:ext>
+            </a:extLst>
+          </p:cNvPr>
+          <p:cNvSpPr>
+            <a:spLocks noGrp="1"/>
+          </p:cNvSpPr>
+          <p:nvPr>
+            <p:ph type="ctrTitle"/>
+          </p:nvPr>
+        </p:nvSpPr>
+        <p:spPr>
+          <a:xfrm>
+            <a:off x="685800" y="534924"/>
+            <a:ext cx="7772400" cy="492443"/>
+          </a:xfrm>
+        </p:spPr>
+        <p:txBody>
+          <a:bodyPr/>
+          <a:lstStyle/>
+          <a:p>
+            <a:pPr algn="ctr"/>
+            <a:r>
+              <a:rPr lang="en-GB" dirty="0">
+                <a:solidFill>
+                  <a:srgbClr val="FF0000"/>
+                </a:solidFill>
+              </a:rPr>
+              <a:t>Git Documentation</a:t>
+            </a:r>
+            <a:endParaRPr lang="en-IN" dirty="0"/>
+          </a:p>
+        </p:txBody>
+      </p:sp>
+      <p:sp>
+        <p:nvSpPr>
+          <p:cNvPr id="3" name="Subtitle 2">
+            <a:extLst>
+              <a:ext uri="{FF2B5EF4-FFF2-40B4-BE49-F238E27FC236}">
+                <a16:creationId xmlns:a16="http://schemas.microsoft.com/office/drawing/2014/main" id="{F21D0357-66FF-AA0A-51D7-D265D3775DC8}"/>
+              </a:ext>
+            </a:extLst>
+          </p:cNvPr>
+          <p:cNvSpPr>
+            <a:spLocks noGrp="1"/>
+          </p:cNvSpPr>
+          <p:nvPr>
+            <p:ph type="subTitle" idx="1"/>
+          </p:nvPr>
+        </p:nvSpPr>
+        <p:spPr/>
+        <p:txBody>
+          <a:bodyPr/>
+          <a:lstStyle/>
+          <a:p>
+            <a:endParaRPr lang="en-IN"/>
+          </a:p>
+        </p:txBody>
+      </p:sp>
+      <p:sp>
+        <p:nvSpPr>
+          <p:cNvPr id="4" name="Slide Number Placeholder 3">
+            <a:extLst>
+              <a:ext uri="{FF2B5EF4-FFF2-40B4-BE49-F238E27FC236}">
+                <a16:creationId xmlns:a16="http://schemas.microsoft.com/office/drawing/2014/main" id="{0076BE67-086F-D51F-C8F0-88B98B07943C}"/>
+              </a:ext>
+            </a:extLst>
+          </p:cNvPr>
+          <p:cNvSpPr>
+            <a:spLocks noGrp="1"/>
+          </p:cNvSpPr>
+          <p:nvPr>
+            <p:ph type="sldNum" idx="12"/>
+          </p:nvPr>
+        </p:nvSpPr>
+        <p:spPr/>
+        <p:txBody>
+          <a:bodyPr/>
+          <a:lstStyle/>
+          <a:p>
+            <a:pPr marL="0" lvl="0" indent="0" algn="r" rtl="0">
+              <a:spcBef>
+                <a:spcPts val="0"/>
+              </a:spcBef>
+              <a:spcAft>
+                <a:spcPts val="0"/>
+              </a:spcAft>
+              <a:buNone/>
+            </a:pPr>
+            <a:fld id="{00000000-1234-1234-1234-123412341234}" type="slidenum">
+              <a:rPr lang="en-US" smtClean="0"/>
+              <a:t>13</a:t>
+            </a:fld>
+            <a:endParaRPr lang="en-US"/>
+          </a:p>
+        </p:txBody>
+      </p:sp>
+      <p:pic>
+        <p:nvPicPr>
+          <p:cNvPr id="6" name="Picture 5">
+            <a:extLst>
+              <a:ext uri="{FF2B5EF4-FFF2-40B4-BE49-F238E27FC236}">
+                <a16:creationId xmlns:a16="http://schemas.microsoft.com/office/drawing/2014/main" id="{4927DAC6-AE8C-08CB-64D0-80A36741021A}"/>
+              </a:ext>
+            </a:extLst>
+          </p:cNvPr>
+          <p:cNvPicPr>
+            <a:picLocks noChangeAspect="1"/>
+          </p:cNvPicPr>
+          <p:nvPr/>
+        </p:nvPicPr>
+        <p:blipFill>
+          <a:blip r:embed="rId2"/>
+          <a:stretch>
+            <a:fillRect/>
+          </a:stretch>
+        </p:blipFill>
+        <p:spPr>
+          <a:xfrm>
+            <a:off x="685800" y="1490472"/>
+            <a:ext cx="8001000" cy="4866028"/>
+          </a:xfrm>
+          <a:prstGeom prst="rect">
+            <a:avLst/>
+          </a:prstGeom>
+        </p:spPr>
+      </p:pic>
+    </p:spTree>
+    <p:extLst>
+      <p:ext uri="{BB962C8B-B14F-4D97-AF65-F5344CB8AC3E}">
+        <p14:creationId xmlns:p14="http://schemas.microsoft.com/office/powerpoint/2010/main" val="455542307"/>
+      </p:ext>
+    </p:extLst>
+  </p:cSld>
+  <p:clrMapOvr>
+    <a:masterClrMapping/>
+  </p:clrMapOvr>
+</p:sld>
+</file>
+
+<file path=ppt/slides/slide14.xml><?xml version="1.0" encoding="utf-8"?>
+<p:sld xmlns:a="http://schemas.openxmlformats.org/drawingml/2006/main" xmlns:r="http://schemas.openxmlformats.org/officeDocument/2006/relationships" xmlns:p="http://schemas.openxmlformats.org/presentationml/2006/main">
+  <p:cSld>
+    <p:spTree>
+      <p:nvGrpSpPr>
         <p:cNvPr id="1" name="Shape 61"/>
         <p:cNvGrpSpPr/>
         <p:nvPr/>
@@ -8003,7 +8166,7 @@
             </a:pPr>
             <a:fld id="{00000000-1234-1234-1234-123412341234}" type="slidenum">
               <a:rPr lang="en-US"/>
-              <a:t>13</a:t>
+              <a:t>14</a:t>
             </a:fld>
             <a:endParaRPr/>
           </a:p>
@@ -8288,7 +8451,7 @@
 </p:sld>
 </file>
 
-<file path=ppt/slides/slide14.xml><?xml version="1.0" encoding="utf-8"?>
+<file path=ppt/slides/slide15.xml><?xml version="1.0" encoding="utf-8"?>
 <p:sld xmlns:a="http://schemas.openxmlformats.org/drawingml/2006/main" xmlns:r="http://schemas.openxmlformats.org/officeDocument/2006/relationships" xmlns:p="http://schemas.openxmlformats.org/presentationml/2006/main">
   <p:cSld>
     <p:spTree>
@@ -8395,7 +8558,7 @@
             </a:pPr>
             <a:fld id="{00000000-1234-1234-1234-123412341234}" type="slidenum">
               <a:rPr lang="en-US"/>
-              <a:t>14</a:t>
+              <a:t>15</a:t>
             </a:fld>
             <a:endParaRPr/>
           </a:p>
@@ -8703,7 +8866,7 @@
         </p:nvSpPr>
         <p:spPr>
           <a:xfrm>
-            <a:off x="3399163" y="215003"/>
+            <a:off x="3262003" y="827651"/>
             <a:ext cx="3098259" cy="773016"/>
           </a:xfrm>
           <a:prstGeom prst="rect">
@@ -8720,7 +8883,7 @@
           </a:bodyPr>
           <a:lstStyle/>
           <a:p>
-            <a:pPr marL="12700" lvl="0"/>
+            <a:pPr marL="12700" lvl="0" algn="ctr"/>
             <a:r>
               <a:rPr lang="en-GB" sz="3600" dirty="0">
                 <a:solidFill>
@@ -8793,47 +8956,6 @@
       </p:sp>
       <p:sp>
         <p:nvSpPr>
-          <p:cNvPr id="4" name="Google Shape;53;p1"/>
-          <p:cNvSpPr txBox="1">
-            <a:spLocks noGrp="1"/>
-          </p:cNvSpPr>
-          <p:nvPr>
-            <p:ph type="body" idx="1"/>
-          </p:nvPr>
-        </p:nvSpPr>
-        <p:spPr>
-          <a:xfrm>
-            <a:off x="1517710" y="1203609"/>
-            <a:ext cx="8563183" cy="978463"/>
-          </a:xfrm>
-          <a:prstGeom prst="rect">
-            <a:avLst/>
-          </a:prstGeom>
-          <a:noFill/>
-          <a:ln>
-            <a:noFill/>
-          </a:ln>
-        </p:spPr>
-        <p:txBody>
-          <a:bodyPr spcFirstLastPara="1" wrap="square" lIns="0" tIns="54600" rIns="0" bIns="0" anchor="t" anchorCtr="0">
-            <a:spAutoFit/>
-          </a:bodyPr>
-          <a:lstStyle/>
-          <a:p>
-            <a:endParaRPr lang="en-IN" b="0" dirty="0"/>
-          </a:p>
-          <a:p>
-            <a:pPr marL="228600" indent="0"/>
-            <a:endParaRPr lang="en-IN" b="0" dirty="0"/>
-          </a:p>
-          <a:p>
-            <a:pPr marL="228600" indent="0"/>
-            <a:endParaRPr lang="en-IN" b="0" dirty="0"/>
-          </a:p>
-        </p:txBody>
-      </p:sp>
-      <p:sp>
-        <p:nvSpPr>
           <p:cNvPr id="3" name="Rectangle 2">
             <a:extLst>
               <a:ext uri="{FF2B5EF4-FFF2-40B4-BE49-F238E27FC236}">
@@ -8848,8 +8970,8 @@
         </p:nvSpPr>
         <p:spPr bwMode="auto">
           <a:xfrm>
-            <a:off x="1155554" y="1538739"/>
-            <a:ext cx="8925339" cy="3780522"/>
+            <a:off x="1155554" y="2161217"/>
+            <a:ext cx="8925339" cy="2535566"/>
           </a:xfrm>
           <a:prstGeom prst="rect">
             <a:avLst/>
@@ -8897,139 +9019,47 @@
           </a:bodyPr>
           <a:lstStyle/>
           <a:p>
-            <a:pPr>
+            <a:pPr marL="285750" indent="-285750">
               <a:lnSpc>
                 <a:spcPct val="150000"/>
               </a:lnSpc>
+              <a:buFont typeface="Arial" panose="020B0604020202020204" pitchFamily="34" charset="0"/>
+              <a:buChar char="•"/>
             </a:pPr>
             <a:r>
-              <a:rPr lang="en-GB" sz="1800" b="1" dirty="0">
+              <a:rPr lang="en-IN" sz="1800" dirty="0">
                 <a:latin typeface="Times New Roman" panose="02020603050405020304" pitchFamily="18" charset="0"/>
                 <a:cs typeface="Times New Roman" panose="02020603050405020304" pitchFamily="18" charset="0"/>
               </a:rPr>
-              <a:t>Primary Objective:</a:t>
-            </a:r>
-          </a:p>
-          <a:p>
-            <a:pPr>
+              <a:t>Predict concrete compressive strength. </a:t>
+            </a:r>
+          </a:p>
+          <a:p>
+            <a:pPr marL="285750" indent="-285750">
               <a:lnSpc>
                 <a:spcPct val="150000"/>
               </a:lnSpc>
+              <a:buFont typeface="Arial" panose="020B0604020202020204" pitchFamily="34" charset="0"/>
+              <a:buChar char="•"/>
             </a:pPr>
             <a:r>
-              <a:rPr lang="en-GB" sz="1800" dirty="0">
+              <a:rPr lang="en-IN" sz="1800" dirty="0">
                 <a:latin typeface="Times New Roman" panose="02020603050405020304" pitchFamily="18" charset="0"/>
                 <a:cs typeface="Times New Roman" panose="02020603050405020304" pitchFamily="18" charset="0"/>
               </a:rPr>
-              <a:t>Develop an interpretable machine learning model for predicting concrete</a:t>
-            </a:r>
-          </a:p>
-          <a:p>
-            <a:pPr>
+              <a:t>Compare Machine Learning models. </a:t>
+            </a:r>
+          </a:p>
+          <a:p>
+            <a:pPr marL="285750" indent="-285750">
               <a:lnSpc>
                 <a:spcPct val="150000"/>
               </a:lnSpc>
+              <a:buFont typeface="Arial" panose="020B0604020202020204" pitchFamily="34" charset="0"/>
+              <a:buChar char="•"/>
             </a:pPr>
             <a:r>
-              <a:rPr lang="en-GB" sz="1800" dirty="0">
-                <a:latin typeface="Times New Roman" panose="02020603050405020304" pitchFamily="18" charset="0"/>
-                <a:cs typeface="Times New Roman" panose="02020603050405020304" pitchFamily="18" charset="0"/>
-              </a:rPr>
-              <a:t> compressive strength.</a:t>
-            </a:r>
-          </a:p>
-          <a:p>
-            <a:pPr>
-              <a:lnSpc>
-                <a:spcPct val="150000"/>
-              </a:lnSpc>
-            </a:pPr>
-            <a:r>
-              <a:rPr lang="en-GB" sz="1800" b="1" dirty="0">
-                <a:latin typeface="Times New Roman" panose="02020603050405020304" pitchFamily="18" charset="0"/>
-                <a:cs typeface="Times New Roman" panose="02020603050405020304" pitchFamily="18" charset="0"/>
-              </a:rPr>
-              <a:t>Specific Objectives:</a:t>
-            </a:r>
-          </a:p>
-          <a:p>
-            <a:pPr>
-              <a:lnSpc>
-                <a:spcPct val="150000"/>
-              </a:lnSpc>
-            </a:pPr>
-            <a:r>
-              <a:rPr lang="en-GB" sz="1800" dirty="0">
-                <a:latin typeface="Times New Roman" panose="02020603050405020304" pitchFamily="18" charset="0"/>
-                <a:cs typeface="Times New Roman" panose="02020603050405020304" pitchFamily="18" charset="0"/>
-              </a:rPr>
-              <a:t>Collect and preprocess concrete datasets. </a:t>
-            </a:r>
-          </a:p>
-          <a:p>
-            <a:pPr>
-              <a:lnSpc>
-                <a:spcPct val="150000"/>
-              </a:lnSpc>
-            </a:pPr>
-            <a:r>
-              <a:rPr lang="en-GB" sz="1800" dirty="0">
-                <a:latin typeface="Times New Roman" panose="02020603050405020304" pitchFamily="18" charset="0"/>
-                <a:cs typeface="Times New Roman" panose="02020603050405020304" pitchFamily="18" charset="0"/>
-              </a:rPr>
-              <a:t>Train ML models such as </a:t>
-            </a:r>
-            <a:r>
-              <a:rPr lang="en-GB" sz="1800" dirty="0" err="1">
-                <a:latin typeface="Times New Roman" panose="02020603050405020304" pitchFamily="18" charset="0"/>
-                <a:cs typeface="Times New Roman" panose="02020603050405020304" pitchFamily="18" charset="0"/>
-              </a:rPr>
-              <a:t>XGBoost</a:t>
-            </a:r>
-            <a:r>
-              <a:rPr lang="en-GB" sz="1800" dirty="0">
-                <a:latin typeface="Times New Roman" panose="02020603050405020304" pitchFamily="18" charset="0"/>
-                <a:cs typeface="Times New Roman" panose="02020603050405020304" pitchFamily="18" charset="0"/>
-              </a:rPr>
-              <a:t> and </a:t>
-            </a:r>
-            <a:r>
-              <a:rPr lang="en-GB" sz="1800" dirty="0" err="1">
-                <a:latin typeface="Times New Roman" panose="02020603050405020304" pitchFamily="18" charset="0"/>
-                <a:cs typeface="Times New Roman" panose="02020603050405020304" pitchFamily="18" charset="0"/>
-              </a:rPr>
-              <a:t>CatBoost</a:t>
-            </a:r>
-            <a:r>
-              <a:rPr lang="en-GB" sz="1800" dirty="0">
-                <a:latin typeface="Times New Roman" panose="02020603050405020304" pitchFamily="18" charset="0"/>
-                <a:cs typeface="Times New Roman" panose="02020603050405020304" pitchFamily="18" charset="0"/>
-              </a:rPr>
-              <a:t>. </a:t>
-            </a:r>
-          </a:p>
-          <a:p>
-            <a:pPr>
-              <a:lnSpc>
-                <a:spcPct val="150000"/>
-              </a:lnSpc>
-            </a:pPr>
-            <a:r>
-              <a:rPr lang="en-GB" sz="1800" dirty="0">
-                <a:latin typeface="Times New Roman" panose="02020603050405020304" pitchFamily="18" charset="0"/>
-                <a:cs typeface="Times New Roman" panose="02020603050405020304" pitchFamily="18" charset="0"/>
-              </a:rPr>
-              <a:t>Compare model performance. </a:t>
-            </a:r>
-          </a:p>
-          <a:p>
-            <a:pPr>
-              <a:lnSpc>
-                <a:spcPct val="150000"/>
-              </a:lnSpc>
-            </a:pPr>
-            <a:r>
-              <a:rPr lang="en-GB" sz="1800" dirty="0">
+              <a:rPr lang="en-IN" sz="1800" dirty="0">
                 <a:latin typeface="Times New Roman" panose="02020603050405020304" pitchFamily="18" charset="0"/>
                 <a:cs typeface="Times New Roman" panose="02020603050405020304" pitchFamily="18" charset="0"/>
               </a:rPr>
@@ -9037,17 +9067,51 @@
             </a:r>
           </a:p>
           <a:p>
-            <a:pPr>
+            <a:pPr marL="285750" indent="-285750">
               <a:lnSpc>
                 <a:spcPct val="150000"/>
               </a:lnSpc>
+              <a:buFont typeface="Arial" panose="020B0604020202020204" pitchFamily="34" charset="0"/>
+              <a:buChar char="•"/>
             </a:pPr>
             <a:r>
-              <a:rPr lang="en-GB" sz="1800" dirty="0">
+              <a:rPr lang="en-IN" sz="1800" dirty="0">
                 <a:latin typeface="Times New Roman" panose="02020603050405020304" pitchFamily="18" charset="0"/>
                 <a:cs typeface="Times New Roman" panose="02020603050405020304" pitchFamily="18" charset="0"/>
               </a:rPr>
-              <a:t>Develop a user-friendly prediction interface.</a:t>
+              <a:t>Optimize cost and carbon emission. </a:t>
+            </a:r>
+          </a:p>
+          <a:p>
+            <a:pPr marL="285750" indent="-285750">
+              <a:lnSpc>
+                <a:spcPct val="150000"/>
+              </a:lnSpc>
+              <a:buFont typeface="Arial" panose="020B0604020202020204" pitchFamily="34" charset="0"/>
+              <a:buChar char="•"/>
+            </a:pPr>
+            <a:r>
+              <a:rPr lang="en-IN" sz="1800" dirty="0">
+                <a:latin typeface="Times New Roman" panose="02020603050405020304" pitchFamily="18" charset="0"/>
+                <a:cs typeface="Times New Roman" panose="02020603050405020304" pitchFamily="18" charset="0"/>
+              </a:rPr>
+              <a:t>Recommend the best concrete mix. </a:t>
+            </a:r>
+          </a:p>
+          <a:p>
+            <a:pPr marL="285750" indent="-285750">
+              <a:lnSpc>
+                <a:spcPct val="150000"/>
+              </a:lnSpc>
+              <a:buFont typeface="Arial" panose="020B0604020202020204" pitchFamily="34" charset="0"/>
+              <a:buChar char="•"/>
+            </a:pPr>
+            <a:r>
+              <a:rPr lang="en-IN" sz="1800" dirty="0">
+                <a:latin typeface="Times New Roman" panose="02020603050405020304" pitchFamily="18" charset="0"/>
+                <a:cs typeface="Times New Roman" panose="02020603050405020304" pitchFamily="18" charset="0"/>
+              </a:rPr>
+              <a:t>Develop a user-friendly dashboard. </a:t>
             </a:r>
           </a:p>
         </p:txBody>

</xml_diff>